<commit_message>
Disclosure, offline-safety proof, and training-hygiene framing
- EXTERNAL_RESOURCES.md opens with an affirmative summary: no external datasets,
  no pretrained weights in the submitted model, LPIPS pretrained backbone used for
  evaluation only with package, link and licence read from the shipped LICENSE file.
- Verified inference.py has no LPIPS dependency: traced its full transitive import
  graph (1108 modules; lpips/torchvision/skimage absent) and re-ran it with those
  packages unimportable and sockets disabled -> 400/400 bit-identical outputs.
  No code change was needed; the lpips import was already function-local.
- Repo deck conclusion slide: disclosure expanded, and the early stop reframed as a
  training-hygiene finding naming the cause (3000 images vs 4.02M params, no weight
  decay) and the next step (weight decay).
- Portal deck rebuilt as ViSaSha_PS01, video placeholder removed entirely.

Co-Authored-By: Claude Opus 5 <noreply@anthropic.com>
</commit_message>
<xml_diff>
--- a/solution_presentation.pptx
+++ b/solution_presentation.pptx
@@ -4102,7 +4102,7 @@
         </p:nvSpPr>
         <p:spPr>
           <a:xfrm>
-            <a:off x="566928" y="1408176"/>
+            <a:off x="566928" y="1335024"/>
             <a:ext cx="384048" cy="384048"/>
           </a:xfrm>
           <a:prstGeom prst="ellipse">
@@ -4127,7 +4127,7 @@
         </p:nvSpPr>
         <p:spPr>
           <a:xfrm>
-            <a:off x="566928" y="1408176"/>
+            <a:off x="566928" y="1335024"/>
             <a:ext cx="384048" cy="384048"/>
           </a:xfrm>
           <a:prstGeom prst="rect">
@@ -4166,8 +4166,8 @@
         </p:nvSpPr>
         <p:spPr>
           <a:xfrm>
-            <a:off x="1133856" y="1371600"/>
-            <a:ext cx="6766560" cy="329184"/>
+            <a:off x="1133856" y="1298448"/>
+            <a:ext cx="6537960" cy="329184"/>
           </a:xfrm>
           <a:prstGeom prst="rect">
             <a:avLst/>
@@ -4205,8 +4205,8 @@
         </p:nvSpPr>
         <p:spPr>
           <a:xfrm>
-            <a:off x="1133856" y="1700784"/>
-            <a:ext cx="6766560" cy="603504"/>
+            <a:off x="1133856" y="1600200"/>
+            <a:ext cx="6537960" cy="822960"/>
           </a:xfrm>
           <a:prstGeom prst="rect">
             <a:avLst/>
@@ -4220,12 +4220,12 @@
           <a:p>
             <a:pPr indent="0" marL="0">
               <a:lnSpc>
-                <a:spcPts val="1450"/>
+                <a:spcPts val="1280"/>
               </a:lnSpc>
               <a:buNone/>
             </a:pPr>
             <a:r>
-              <a:rPr lang="en-US" sz="1150" dirty="0">
+              <a:rPr lang="en-US" sz="1000" dirty="0">
                 <a:solidFill>
                   <a:srgbClr val="A8BDD0"/>
                 </a:solidFill>
@@ -4235,7 +4235,7 @@
               </a:rPr>
               <a:t>27.52 dB vs 22.73 dB bicubic (+4.79 dB), on a held-out split never used for training</a:t>
             </a:r>
-            <a:endParaRPr lang="en-US" sz="1150" dirty="0"/>
+            <a:endParaRPr lang="en-US" sz="1000" dirty="0"/>
           </a:p>
         </p:txBody>
       </p:sp>
@@ -4247,7 +4247,7 @@
         </p:nvSpPr>
         <p:spPr>
           <a:xfrm>
-            <a:off x="566928" y="2432304"/>
+            <a:off x="566928" y="2414016"/>
             <a:ext cx="384048" cy="384048"/>
           </a:xfrm>
           <a:prstGeom prst="ellipse">
@@ -4272,7 +4272,7 @@
         </p:nvSpPr>
         <p:spPr>
           <a:xfrm>
-            <a:off x="566928" y="2432304"/>
+            <a:off x="566928" y="2414016"/>
             <a:ext cx="384048" cy="384048"/>
           </a:xfrm>
           <a:prstGeom prst="rect">
@@ -4311,8 +4311,8 @@
         </p:nvSpPr>
         <p:spPr>
           <a:xfrm>
-            <a:off x="1133856" y="2395728"/>
-            <a:ext cx="6766560" cy="329184"/>
+            <a:off x="1133856" y="2377440"/>
+            <a:ext cx="6537960" cy="329184"/>
           </a:xfrm>
           <a:prstGeom prst="rect">
             <a:avLst/>
@@ -4350,8 +4350,8 @@
         </p:nvSpPr>
         <p:spPr>
           <a:xfrm>
-            <a:off x="1133856" y="2724912"/>
-            <a:ext cx="6766560" cy="603504"/>
+            <a:off x="1133856" y="2679192"/>
+            <a:ext cx="6537960" cy="822960"/>
           </a:xfrm>
           <a:prstGeom prst="rect">
             <a:avLst/>
@@ -4365,12 +4365,12 @@
           <a:p>
             <a:pPr indent="0" marL="0">
               <a:lnSpc>
-                <a:spcPts val="1450"/>
+                <a:spcPts val="1280"/>
               </a:lnSpc>
               <a:buNone/>
             </a:pPr>
             <a:r>
-              <a:rPr lang="en-US" sz="1150" dirty="0">
+              <a:rPr lang="en-US" sz="1000" dirty="0">
                 <a:solidFill>
                   <a:srgbClr val="A8BDD0"/>
                 </a:solidFill>
@@ -4380,7 +4380,7 @@
               </a:rPr>
               <a:t>One config, one seed, committed val split, git hash inside every checkpoint, metrics computed from the saved files</a:t>
             </a:r>
-            <a:endParaRPr lang="en-US" sz="1150" dirty="0"/>
+            <a:endParaRPr lang="en-US" sz="1000" dirty="0"/>
           </a:p>
         </p:txBody>
       </p:sp>
@@ -4392,7 +4392,7 @@
         </p:nvSpPr>
         <p:spPr>
           <a:xfrm>
-            <a:off x="566928" y="3456432"/>
+            <a:off x="566928" y="3493008"/>
             <a:ext cx="384048" cy="384048"/>
           </a:xfrm>
           <a:prstGeom prst="ellipse">
@@ -4417,7 +4417,7 @@
         </p:nvSpPr>
         <p:spPr>
           <a:xfrm>
-            <a:off x="566928" y="3456432"/>
+            <a:off x="566928" y="3493008"/>
             <a:ext cx="384048" cy="384048"/>
           </a:xfrm>
           <a:prstGeom prst="rect">
@@ -4456,8 +4456,8 @@
         </p:nvSpPr>
         <p:spPr>
           <a:xfrm>
-            <a:off x="1133856" y="3419856"/>
-            <a:ext cx="6766560" cy="329184"/>
+            <a:off x="1133856" y="3456432"/>
+            <a:ext cx="6537960" cy="329184"/>
           </a:xfrm>
           <a:prstGeom prst="rect">
             <a:avLst/>
@@ -4481,7 +4481,7 @@
                 <a:ea typeface="Cambria" pitchFamily="34" charset="-122"/>
                 <a:cs typeface="Cambria" pitchFamily="34" charset="-120"/>
               </a:rPr>
-              <a:t>Honest about its limits</a:t>
+              <a:t>Training hygiene: we caught our own overfitting</a:t>
             </a:r>
             <a:endParaRPr lang="en-US" sz="1600" dirty="0"/>
           </a:p>
@@ -4495,8 +4495,8 @@
         </p:nvSpPr>
         <p:spPr>
           <a:xfrm>
-            <a:off x="1133856" y="3749040"/>
-            <a:ext cx="6766560" cy="603504"/>
+            <a:off x="1133856" y="3758184"/>
+            <a:ext cx="6537960" cy="822960"/>
           </a:xfrm>
           <a:prstGeom prst="rect">
             <a:avLst/>
@@ -4510,12 +4510,12 @@
           <a:p>
             <a:pPr indent="0" marL="0">
               <a:lnSpc>
-                <a:spcPts val="1450"/>
+                <a:spcPts val="1280"/>
               </a:lnSpc>
               <a:buNone/>
             </a:pPr>
             <a:r>
-              <a:rPr lang="en-US" sz="1150" dirty="0">
+              <a:rPr lang="en-US" sz="1000" dirty="0">
                 <a:solidFill>
                   <a:srgbClr val="A8BDD0"/>
                 </a:solidFill>
@@ -4523,9 +4523,9 @@
                 <a:ea typeface="Calibri" pitchFamily="34" charset="-122"/>
                 <a:cs typeface="Calibri" pitchFamily="34" charset="-120"/>
               </a:rPr>
-              <a:t>Stopped early at ~9.4k of 15k iterations once validation peaked and began degrading — the overfitting is reported, not hidden. One seed, one config, laptop-GPU timings.</a:t>
-            </a:r>
-            <a:endParaRPr lang="en-US" sz="1150" dirty="0"/>
+              <a:t>Validation PSNR peaked at step 4,000 of the approved 15,000 while training loss kept falling. We identified this as overfitting — 3,000 images against 4.02 M parameters, no weight decay — stopped at ~9.4k and submitted the peak checkpoint best.pt had already captured. Next step is weight decay, not more steps.</a:t>
+            </a:r>
+            <a:endParaRPr lang="en-US" sz="1000" dirty="0"/>
           </a:p>
         </p:txBody>
       </p:sp>
@@ -4576,8 +4576,8 @@
         </p:nvSpPr>
         <p:spPr>
           <a:xfrm>
-            <a:off x="7955280" y="1737360"/>
-            <a:ext cx="3749040" cy="3108960"/>
+            <a:off x="7955280" y="1719072"/>
+            <a:ext cx="3749040" cy="3291840"/>
           </a:xfrm>
           <a:prstGeom prst="rect">
             <a:avLst/>
@@ -4591,12 +4591,12 @@
           <a:p>
             <a:pPr indent="0" marL="0">
               <a:lnSpc>
-                <a:spcPts val="1400"/>
+                <a:spcPts val="1200"/>
               </a:lnSpc>
               <a:buNone/>
             </a:pPr>
             <a:r>
-              <a:rPr lang="en-US" sz="1050" dirty="0">
+              <a:rPr lang="en-US" sz="900" dirty="0">
                 <a:solidFill>
                   <a:srgbClr val="A8BDD0"/>
                 </a:solidFill>
@@ -4604,28 +4604,48 @@
                 <a:ea typeface="Calibri" pitchFamily="34" charset="-122"/>
                 <a:cs typeface="Calibri" pitchFamily="34" charset="-120"/>
               </a:rPr>
-              <a:t>No external datasets were used.</a:t>
-            </a:r>
-            <a:endParaRPr lang="en-US" sz="1050" dirty="0"/>
+              <a:t>External datasets used: NONE.</a:t>
+            </a:r>
+            <a:endParaRPr lang="en-US" sz="900" dirty="0"/>
           </a:p>
           <a:p>
             <a:pPr indent="0" marL="0">
               <a:lnSpc>
-                <a:spcPts val="1400"/>
+                <a:spcPts val="1200"/>
               </a:lnSpc>
               <a:buNone/>
             </a:pPr>
-            <a:endParaRPr lang="en-US" sz="1050" dirty="0"/>
+            <a:r>
+              <a:rPr lang="en-US" sz="900" dirty="0">
+                <a:solidFill>
+                  <a:srgbClr val="A8BDD0"/>
+                </a:solidFill>
+                <a:latin typeface="Calibri" pitchFamily="34" charset="0"/>
+                <a:ea typeface="Calibri" pitchFamily="34" charset="-122"/>
+                <a:cs typeface="Calibri" pitchFamily="34" charset="-120"/>
+              </a:rPr>
+              <a:t>Pretrained weights in the submitted model: NONE — trained from random initialization on the organizer pairs only.</a:t>
+            </a:r>
+            <a:endParaRPr lang="en-US" sz="900" dirty="0"/>
           </a:p>
           <a:p>
             <a:pPr indent="0" marL="0">
               <a:lnSpc>
-                <a:spcPts val="1400"/>
+                <a:spcPts val="1200"/>
               </a:lnSpc>
               <a:buNone/>
             </a:pPr>
-            <a:r>
-              <a:rPr lang="en-US" sz="1050" dirty="0">
+            <a:endParaRPr lang="en-US" sz="900" dirty="0"/>
+          </a:p>
+          <a:p>
+            <a:pPr indent="0" marL="0">
+              <a:lnSpc>
+                <a:spcPts val="1200"/>
+              </a:lnSpc>
+              <a:buNone/>
+            </a:pPr>
+            <a:r>
+              <a:rPr lang="en-US" sz="900" dirty="0">
                 <a:solidFill>
                   <a:srgbClr val="A8BDD0"/>
                 </a:solidFill>
@@ -4633,28 +4653,28 @@
                 <a:ea typeface="Calibri" pitchFamily="34" charset="-122"/>
                 <a:cs typeface="Calibri" pitchFamily="34" charset="-120"/>
               </a:rPr>
-              <a:t>No pretrained weights are used in the submitted model — it is trained from random initialization on the organizer pairs only.</a:t>
-            </a:r>
-            <a:endParaRPr lang="en-US" sz="1050" dirty="0"/>
+              <a:t>Evaluation only: LPIPS (pypi lpips 0.1.4, github.com/richzhang/PerceptualSimilarity, BSD-2) and its AlexNet backbone (torchvision, BSD-3). Both licences were read from the shipped LICENSE files, not from memory. Neither is imported by inference.py — verified by tracing its full import graph and re-running it with those packages blocked and sockets disabled.</a:t>
+            </a:r>
+            <a:endParaRPr lang="en-US" sz="900" dirty="0"/>
           </a:p>
           <a:p>
             <a:pPr indent="0" marL="0">
               <a:lnSpc>
-                <a:spcPts val="1400"/>
+                <a:spcPts val="1200"/>
               </a:lnSpc>
               <a:buNone/>
             </a:pPr>
-            <a:endParaRPr lang="en-US" sz="1050" dirty="0"/>
+            <a:endParaRPr lang="en-US" sz="900" dirty="0"/>
           </a:p>
           <a:p>
             <a:pPr indent="0" marL="0">
               <a:lnSpc>
-                <a:spcPts val="1400"/>
+                <a:spcPts val="1200"/>
               </a:lnSpc>
               <a:buNone/>
             </a:pPr>
             <a:r>
-              <a:rPr lang="en-US" sz="1050" dirty="0">
+              <a:rPr lang="en-US" sz="900" dirty="0">
                 <a:solidFill>
                   <a:srgbClr val="A8BDD0"/>
                 </a:solidFill>
@@ -4662,28 +4682,28 @@
                 <a:ea typeface="Calibri" pitchFamily="34" charset="-122"/>
                 <a:cs typeface="Calibri" pitchFamily="34" charset="-120"/>
               </a:rPr>
-              <a:t>LPIPS (BSD-2) and its AlexNet backbone (BSD-3) are used for evaluation only. Licences were read from the shipped LICENSE files and recorded in EXTERNAL_RESOURCES.md.</a:t>
-            </a:r>
-            <a:endParaRPr lang="en-US" sz="1050" dirty="0"/>
+              <a:t>Test_NoisyLR was used only to produce submission outputs — never trained on, never validated on.</a:t>
+            </a:r>
+            <a:endParaRPr lang="en-US" sz="900" dirty="0"/>
           </a:p>
           <a:p>
             <a:pPr indent="0" marL="0">
               <a:lnSpc>
-                <a:spcPts val="1400"/>
+                <a:spcPts val="1200"/>
               </a:lnSpc>
               <a:buNone/>
             </a:pPr>
-            <a:endParaRPr lang="en-US" sz="1050" dirty="0"/>
+            <a:endParaRPr lang="en-US" sz="900" dirty="0"/>
           </a:p>
           <a:p>
             <a:pPr indent="0" marL="0">
               <a:lnSpc>
-                <a:spcPts val="1400"/>
+                <a:spcPts val="1200"/>
               </a:lnSpc>
               <a:buNone/>
             </a:pPr>
             <a:r>
-              <a:rPr lang="en-US" sz="1050" dirty="0">
+              <a:rPr lang="en-US" sz="900" dirty="0">
                 <a:solidFill>
                   <a:srgbClr val="A8BDD0"/>
                 </a:solidFill>
@@ -4691,9 +4711,9 @@
                 <a:ea typeface="Calibri" pitchFamily="34" charset="-122"/>
                 <a:cs typeface="Calibri" pitchFamily="34" charset="-120"/>
               </a:rPr>
-              <a:t>Test_NoisyLR was used only to produce submission outputs.</a:t>
-            </a:r>
-            <a:endParaRPr lang="en-US" sz="1050" dirty="0"/>
+              <a:t>Full detail in EXTERNAL_RESOURCES.md.</a:t>
+            </a:r>
+            <a:endParaRPr lang="en-US" sz="900" dirty="0"/>
           </a:p>
         </p:txBody>
       </p:sp>
@@ -4705,7 +4725,7 @@
         </p:nvSpPr>
         <p:spPr>
           <a:xfrm>
-            <a:off x="566928" y="4626864"/>
+            <a:off x="566928" y="4791456"/>
             <a:ext cx="6949440" cy="274320"/>
           </a:xfrm>
           <a:prstGeom prst="rect">
@@ -4744,7 +4764,7 @@
         </p:nvSpPr>
         <p:spPr>
           <a:xfrm>
-            <a:off x="566928" y="4901184"/>
+            <a:off x="566928" y="5065776"/>
             <a:ext cx="6766560" cy="237744"/>
           </a:xfrm>
           <a:prstGeom prst="rect">

</xml_diff>